<commit_message>
speech text and presentation conclusion update
</commit_message>
<xml_diff>
--- a/presentation/report_presentation.pptx
+++ b/presentation/report_presentation.pptx
@@ -1463,7 +1463,7 @@
         </p:nvSpPr>
         <p:spPr>
           <a:xfrm>
-            <a:off x="640080" y="822960"/>
+            <a:off x="640080" y="971550"/>
             <a:ext cx="7863840" cy="731520"/>
           </a:xfrm>
           <a:prstGeom prst="rect">
@@ -1866,7 +1866,7 @@
                   <a:srgbClr val="AADFC8"/>
                 </a:solidFill>
               </a:rPr>
-              <a:t>Five consistency scenarios demonstrated on real hardware — no containers, no simulated latency</a:t>
+              <a:t>Five consistency experiments on a real MongoDB replica set (PRIMARY 192.168.88.30 / SECONDARY 192.168.88.70) — real hardware, real network, real data</a:t>
             </a:r>
             <a:endParaRPr lang="en-US" sz="1200" dirty="0"/>
           </a:p>
@@ -2038,7 +2038,7 @@
                   <a:srgbClr val="D1FAE5"/>
                 </a:solidFill>
               </a:rPr>
-              <a:t>166.4 ms total write — both nodes consistent before client receives ok</a:t>
+              <a:t>SYNC-EXP inserted at Istanbul/Besiktas (positions); both nodes consistent before client receives ok</a:t>
             </a:r>
             <a:endParaRPr lang="en-US" sz="1100" dirty="0"/>
           </a:p>
@@ -2157,7 +2157,7 @@
         <p:spPr>
           <a:xfrm>
             <a:off x="960120" y="2304288"/>
-            <a:ext cx="7680960" cy="310896"/>
+            <a:ext cx="7680960" cy="267462"/>
           </a:xfrm>
           <a:prstGeom prst="rect">
             <a:avLst/>
@@ -2178,7 +2178,7 @@
                   <a:srgbClr val="D1FAE5"/>
                 </a:solidFill>
               </a:rPr>
-              <a:t>2/3 reads stale; system converges within 1163 ms (1 s artificial delay)</a:t>
+              <a:t>EC-BASE updated Ankara → Istanbul — converges within 1189 ms (secondaryDelaySecs=1 artificial delay, real oplog: 75.97 ms)</a:t>
             </a:r>
             <a:endParaRPr lang="en-US" sz="1100" dirty="0"/>
           </a:p>
@@ -2318,7 +2318,7 @@
                   <a:srgbClr val="D1FAE5"/>
                 </a:solidFill>
               </a:rPr>
-              <a:t>PRIMARY read 6.5 ms — always fresh; SECONDARY briefly stale (~3.9 ms to catch up)</a:t>
+              <a:t>PRIMARY read in 0.96 ms always fresh; RAW-EXP incident (breakdown/critical) visible on PRIMARY instantly; SECONDARY syncs within 5 ms</a:t>
             </a:r>
             <a:endParaRPr lang="en-US" sz="1100" dirty="0"/>
           </a:p>
@@ -2458,7 +2458,7 @@
                   <a:srgbClr val="D1FAE5"/>
                 </a:solidFill>
               </a:rPr>
-              <a:t>Versions [5,5,5,5,5], 0 backward reads — oplog ordering forbids regression</a:t>
+              <a:t>Versions seen [1, 2, 2, 3, 3] — never backwards; 0 regressions on MON-EXP shipment (DEP-IST → DEP-ANK); oplog ordering guarantees monotonicity</a:t>
             </a:r>
             <a:endParaRPr lang="en-US" sz="1100" dirty="0"/>
           </a:p>
@@ -2598,7 +2598,7 @@
                   <a:srgbClr val="D1FAE5"/>
                 </a:solidFill>
               </a:rPr>
-              <a:t>log_index 744–749 — write order preserved exactly on SECONDARY</a:t>
+              <a:t>4 concurrent updates to CW-SHARED (vehicles) by User A + B; PRIMARY serialised all writes; SECONDARY converged to final value in 2.5 ms, order preserved</a:t>
             </a:r>
             <a:endParaRPr lang="en-US" sz="1100" dirty="0"/>
           </a:p>
@@ -2666,7 +2666,7 @@
                   <a:srgbClr val="7DC8A8"/>
                 </a:solidFill>
               </a:rPr>
-              <a:t>The operation_logs collection makes replication delay a first-class measured metric — not an invisible side effect.</a:t>
+              <a:t>The operation_logs collection makes replication delay a first-class measured metric — not an invisible side effect of the consistency model chosen.</a:t>
             </a:r>
             <a:endParaRPr lang="en-US" sz="950" dirty="0"/>
           </a:p>

</xml_diff>